<commit_message>
[2026-05-29 UTC] JST refactor to_dict and update PPT template
1. src/client.py: refactor to_dict() to parse Solution custom field into Module/Diff subfields, skip Review Results, include non-null custom fields
2. PPTTemplate/Template.pptx: update design assets

Co-authored-by: Cursor <cursoragent@cursor.com>
</commit_message>
<xml_diff>
--- a/PPTTemplate/Template.pptx
+++ b/PPTTemplate/Template.pptx
@@ -13,7 +13,7 @@
   <p:sldIdLst>
     <p:sldId id="1248" r:id="rId2"/>
     <p:sldId id="1397" r:id="rId3"/>
-    <p:sldId id="1394" r:id="rId4"/>
+    <p:sldId id="1399" r:id="rId4"/>
   </p:sldIdLst>
   <p:sldSz cx="24384000" cy="13716000"/>
   <p:notesSz cx="6858000" cy="9144000"/>
@@ -319,7 +319,7 @@
         <p14:section name="Section" id="{CF033A8C-7F22-4AE0-A6A5-0B754B0C7A49}">
           <p14:sldIdLst>
             <p14:sldId id="1397"/>
-            <p14:sldId id="1394"/>
+            <p14:sldId id="1399"/>
           </p14:sldIdLst>
         </p14:section>
       </p14:sectionLst>
@@ -17317,7 +17317,7 @@
                         <a:t>T</a:t>
                       </a:r>
                       <a:r>
-                        <a:rPr lang="en-US" altLang="zh-CN" sz="3600" b="0" i="0" u="none" strike="noStrike" cap="none" spc="0" baseline="0">
+                        <a:rPr lang="en-US" altLang="zh-CN" sz="3600" b="0" i="0" u="none" strike="noStrike" cap="none" spc="0" baseline="0" dirty="0" err="1">
                           <a:solidFill>
                             <a:schemeClr val="tx1"/>
                           </a:solidFill>
@@ -17602,62 +17602,7 @@
                 <a:ea typeface="Calibri" panose="020F0502020204030204" pitchFamily="34" charset="0"/>
                 <a:cs typeface="Calibri" panose="020F0502020204030204" pitchFamily="34" charset="0"/>
               </a:rPr>
-              <a:t>VEL-16278【#4.5(Lexus)】【</a:t>
-            </a:r>
-            <a:r>
-              <a:rPr lang="zh-CN" altLang="en-US" sz="3200" dirty="0">
-                <a:solidFill>
-                  <a:schemeClr val="tx2"/>
-                </a:solidFill>
-                <a:latin typeface="Calibri" panose="020F0502020204030204" pitchFamily="34" charset="0"/>
-                <a:ea typeface="Calibri" panose="020F0502020204030204" pitchFamily="34" charset="0"/>
-                <a:cs typeface="Calibri" panose="020F0502020204030204" pitchFamily="34" charset="0"/>
-              </a:rPr>
-              <a:t>车模新增</a:t>
-            </a:r>
-            <a:r>
-              <a:rPr lang="en-US" altLang="zh-CN" sz="3200" dirty="0">
-                <a:solidFill>
-                  <a:schemeClr val="tx2"/>
-                </a:solidFill>
-                <a:latin typeface="Calibri" panose="020F0502020204030204" pitchFamily="34" charset="0"/>
-                <a:ea typeface="Calibri" panose="020F0502020204030204" pitchFamily="34" charset="0"/>
-                <a:cs typeface="Calibri" panose="020F0502020204030204" pitchFamily="34" charset="0"/>
-              </a:rPr>
-              <a:t>】【931D】931D</a:t>
-            </a:r>
-            <a:r>
-              <a:rPr lang="zh-CN" altLang="en-US" sz="3200" dirty="0">
-                <a:solidFill>
-                  <a:schemeClr val="tx2"/>
-                </a:solidFill>
-                <a:latin typeface="Calibri" panose="020F0502020204030204" pitchFamily="34" charset="0"/>
-                <a:ea typeface="Calibri" panose="020F0502020204030204" pitchFamily="34" charset="0"/>
-                <a:cs typeface="Calibri" panose="020F0502020204030204" pitchFamily="34" charset="0"/>
-              </a:rPr>
-              <a:t>车模留用</a:t>
-            </a:r>
-            <a:r>
-              <a:rPr lang="en-US" altLang="zh-CN" sz="3200" dirty="0">
-                <a:solidFill>
-                  <a:schemeClr val="tx2"/>
-                </a:solidFill>
-                <a:latin typeface="Calibri" panose="020F0502020204030204" pitchFamily="34" charset="0"/>
-                <a:ea typeface="Calibri" panose="020F0502020204030204" pitchFamily="34" charset="0"/>
-                <a:cs typeface="Calibri" panose="020F0502020204030204" pitchFamily="34" charset="0"/>
-              </a:rPr>
-              <a:t>960B</a:t>
-            </a:r>
-            <a:r>
-              <a:rPr lang="zh-CN" altLang="en-US" sz="3200" dirty="0">
-                <a:solidFill>
-                  <a:schemeClr val="tx2"/>
-                </a:solidFill>
-                <a:latin typeface="Calibri" panose="020F0502020204030204" pitchFamily="34" charset="0"/>
-                <a:ea typeface="Calibri" panose="020F0502020204030204" pitchFamily="34" charset="0"/>
-                <a:cs typeface="Calibri" panose="020F0502020204030204" pitchFamily="34" charset="0"/>
-              </a:rPr>
-              <a:t>个车意匠</a:t>
+              <a:t>[key] [summary]</a:t>
             </a:r>
             <a:endParaRPr lang="zh-CN" altLang="en-US" sz="3200" b="1" dirty="0">
               <a:solidFill>
@@ -17682,7 +17627,7 @@
         <p:spPr>
           <a:xfrm>
             <a:off x="649605" y="1277620"/>
-            <a:ext cx="3773469" cy="1087477"/>
+            <a:ext cx="3683701" cy="1087477"/>
           </a:xfrm>
           <a:prstGeom prst="rect">
             <a:avLst/>
@@ -17724,7 +17669,7 @@
                 <a:latin typeface="Meiryo UI" panose="020B0604030504040204" pitchFamily="34" charset="-128"/>
                 <a:ea typeface="Meiryo UI" panose="020B0604030504040204" pitchFamily="34" charset="-128"/>
               </a:rPr>
-              <a:t>Resource</a:t>
+              <a:t>[Module]</a:t>
             </a:r>
           </a:p>
         </p:txBody>
@@ -17759,6 +17704,68 @@
           </a:prstGeom>
         </p:spPr>
       </p:pic>
+      <p:sp>
+        <p:nvSpPr>
+          <p:cNvPr id="4" name="文本框 3">
+            <a:extLst>
+              <a:ext uri="{FF2B5EF4-FFF2-40B4-BE49-F238E27FC236}">
+                <a16:creationId xmlns:a16="http://schemas.microsoft.com/office/drawing/2014/main" id="{42012226-633A-1A58-4358-728B9A687A3F}"/>
+              </a:ext>
+            </a:extLst>
+          </p:cNvPr>
+          <p:cNvSpPr txBox="1"/>
+          <p:nvPr/>
+        </p:nvSpPr>
+        <p:spPr>
+          <a:xfrm>
+            <a:off x="12673440" y="1272978"/>
+            <a:ext cx="3342262" cy="1087477"/>
+          </a:xfrm>
+          <a:prstGeom prst="rect">
+            <a:avLst/>
+          </a:prstGeom>
+          <a:noFill/>
+          <a:ln w="12700" cap="flat">
+            <a:noFill/>
+            <a:miter lim="400000"/>
+          </a:ln>
+        </p:spPr>
+        <p:style>
+          <a:lnRef idx="0">
+            <a:scrgbClr r="0" g="0" b="0"/>
+          </a:lnRef>
+          <a:fillRef idx="0">
+            <a:scrgbClr r="0" g="0" b="0"/>
+          </a:fillRef>
+          <a:effectRef idx="0">
+            <a:scrgbClr r="0" g="0" b="0"/>
+          </a:effectRef>
+          <a:fontRef idx="none"/>
+        </p:style>
+        <p:txBody>
+          <a:bodyPr rot="0" vertOverflow="overflow" horzOverflow="overflow" vert="horz" wrap="none" lIns="50800" tIns="50800" rIns="50800" bIns="50800" numCol="1" spcCol="38100" rtlCol="0" anchor="t" forceAA="0">
+            <a:spAutoFit/>
+          </a:bodyPr>
+          <a:lstStyle/>
+          <a:p>
+            <a:pPr lvl="0" algn="l">
+              <a:defRPr/>
+            </a:pPr>
+            <a:r>
+              <a:rPr lang="en-US" altLang="zh-CN" sz="6400" dirty="0">
+                <a:solidFill>
+                  <a:srgbClr val="434343">
+                    <a:lumMod val="50000"/>
+                  </a:srgbClr>
+                </a:solidFill>
+                <a:latin typeface="Meiryo UI" panose="020B0604030504040204" pitchFamily="34" charset="-128"/>
+                <a:ea typeface="Meiryo UI" panose="020B0604030504040204" pitchFamily="34" charset="-128"/>
+              </a:rPr>
+              <a:t>Solution</a:t>
+            </a:r>
+          </a:p>
+        </p:txBody>
+      </p:sp>
     </p:spTree>
     <p:extLst>
       <p:ext uri="{BB962C8B-B14F-4D97-AF65-F5344CB8AC3E}">
@@ -17781,7 +17788,7 @@
         <p:cNvPr id="1" name="">
           <a:extLst>
             <a:ext uri="{FF2B5EF4-FFF2-40B4-BE49-F238E27FC236}">
-              <a16:creationId xmlns:a16="http://schemas.microsoft.com/office/drawing/2014/main" id="{3FDC1664-E287-9F7F-E979-0548EFE0B6D9}"/>
+              <a16:creationId xmlns:a16="http://schemas.microsoft.com/office/drawing/2014/main" id="{F6F542D9-AE88-706F-0735-25E661F97D9A}"/>
             </a:ext>
           </a:extLst>
         </p:cNvPr>
@@ -17801,7 +17808,7 @@
           <p:cNvPr id="12" name="文本框 6">
             <a:extLst>
               <a:ext uri="{FF2B5EF4-FFF2-40B4-BE49-F238E27FC236}">
-                <a16:creationId xmlns:a16="http://schemas.microsoft.com/office/drawing/2014/main" id="{E09C3364-C610-12D7-DA96-061BA1E88CE4}"/>
+                <a16:creationId xmlns:a16="http://schemas.microsoft.com/office/drawing/2014/main" id="{C616AC37-0582-BEC0-6E99-71ADFF557283}"/>
               </a:ext>
             </a:extLst>
           </p:cNvPr>
@@ -17811,7 +17818,7 @@
         <p:spPr>
           <a:xfrm>
             <a:off x="294957" y="2716035"/>
-            <a:ext cx="23794085" cy="2108200"/>
+            <a:ext cx="23794085" cy="1891134"/>
           </a:xfrm>
           <a:prstGeom prst="rect">
             <a:avLst/>
@@ -17855,81 +17862,12 @@
                 <a:ea typeface="Calibri" panose="020F0502020204030204" pitchFamily="34" charset="0"/>
                 <a:cs typeface="Calibri" panose="020F0502020204030204" pitchFamily="34" charset="0"/>
               </a:rPr>
-              <a:t>【#4.5(Lexus)】【</a:t>
-            </a:r>
-            <a:r>
-              <a:rPr lang="zh-CN" altLang="en-US" sz="3200" dirty="0">
-                <a:solidFill>
-                  <a:schemeClr val="tx2"/>
-                </a:solidFill>
-                <a:latin typeface="Calibri" panose="020F0502020204030204" pitchFamily="34" charset="0"/>
-                <a:ea typeface="Calibri" panose="020F0502020204030204" pitchFamily="34" charset="0"/>
-                <a:cs typeface="Calibri" panose="020F0502020204030204" pitchFamily="34" charset="0"/>
-              </a:rPr>
-              <a:t>车模新增</a:t>
-            </a:r>
-            <a:r>
-              <a:rPr lang="en-US" altLang="zh-CN" sz="3200" dirty="0">
-                <a:solidFill>
-                  <a:schemeClr val="tx2"/>
-                </a:solidFill>
-                <a:latin typeface="Calibri" panose="020F0502020204030204" pitchFamily="34" charset="0"/>
-                <a:ea typeface="Calibri" panose="020F0502020204030204" pitchFamily="34" charset="0"/>
-                <a:cs typeface="Calibri" panose="020F0502020204030204" pitchFamily="34" charset="0"/>
-              </a:rPr>
-              <a:t>】【931D】931D</a:t>
-            </a:r>
-            <a:r>
-              <a:rPr lang="zh-CN" altLang="en-US" sz="3200" dirty="0">
-                <a:solidFill>
-                  <a:schemeClr val="tx2"/>
-                </a:solidFill>
-                <a:latin typeface="Calibri" panose="020F0502020204030204" pitchFamily="34" charset="0"/>
-                <a:ea typeface="Calibri" panose="020F0502020204030204" pitchFamily="34" charset="0"/>
-                <a:cs typeface="Calibri" panose="020F0502020204030204" pitchFamily="34" charset="0"/>
-              </a:rPr>
-              <a:t>车模留用</a:t>
-            </a:r>
-            <a:r>
-              <a:rPr lang="en-US" altLang="zh-CN" sz="3200" dirty="0">
-                <a:solidFill>
-                  <a:schemeClr val="tx2"/>
-                </a:solidFill>
-                <a:latin typeface="Calibri" panose="020F0502020204030204" pitchFamily="34" charset="0"/>
-                <a:ea typeface="Calibri" panose="020F0502020204030204" pitchFamily="34" charset="0"/>
-                <a:cs typeface="Calibri" panose="020F0502020204030204" pitchFamily="34" charset="0"/>
-              </a:rPr>
-              <a:t>960B</a:t>
-            </a:r>
-            <a:r>
-              <a:rPr lang="zh-CN" altLang="en-US" sz="3200" dirty="0">
-                <a:solidFill>
-                  <a:schemeClr val="tx2"/>
-                </a:solidFill>
-                <a:latin typeface="Calibri" panose="020F0502020204030204" pitchFamily="34" charset="0"/>
-                <a:ea typeface="Calibri" panose="020F0502020204030204" pitchFamily="34" charset="0"/>
-                <a:cs typeface="Calibri" panose="020F0502020204030204" pitchFamily="34" charset="0"/>
-              </a:rPr>
-              <a:t>个车意匠 </a:t>
-            </a:r>
-            <a:r>
-              <a:rPr lang="en-US" altLang="zh-CN" sz="3200" dirty="0">
-                <a:solidFill>
-                  <a:schemeClr val="tx2"/>
-                </a:solidFill>
-                <a:latin typeface="Calibri" panose="020F0502020204030204" pitchFamily="34" charset="0"/>
-                <a:ea typeface="Calibri" panose="020F0502020204030204" pitchFamily="34" charset="0"/>
-                <a:cs typeface="Calibri" panose="020F0502020204030204" pitchFamily="34" charset="0"/>
-              </a:rPr>
-              <a:t>VEL-16278</a:t>
-            </a:r>
-            <a:endParaRPr lang="zh-CN" altLang="en-US" sz="3200" dirty="0">
+              <a:t>[key] [summary]</a:t>
+            </a:r>
+            <a:endParaRPr lang="zh-CN" altLang="en-US" sz="3200" b="1" dirty="0">
               <a:solidFill>
                 <a:schemeClr val="tx2"/>
               </a:solidFill>
-              <a:latin typeface="Calibri" panose="020F0502020204030204" pitchFamily="34" charset="0"/>
-              <a:ea typeface="Calibri" panose="020F0502020204030204" pitchFamily="34" charset="0"/>
-              <a:cs typeface="Calibri" panose="020F0502020204030204" pitchFamily="34" charset="0"/>
             </a:endParaRPr>
           </a:p>
         </p:txBody>
@@ -17939,7 +17877,7 @@
           <p:cNvPr id="8" name="文本框 7">
             <a:extLst>
               <a:ext uri="{FF2B5EF4-FFF2-40B4-BE49-F238E27FC236}">
-                <a16:creationId xmlns:a16="http://schemas.microsoft.com/office/drawing/2014/main" id="{B0BB49FA-E9DE-88E2-E2CE-3DA210791A00}"/>
+                <a16:creationId xmlns:a16="http://schemas.microsoft.com/office/drawing/2014/main" id="{DC0C2705-06BA-0023-569E-65804D90507E}"/>
               </a:ext>
             </a:extLst>
           </p:cNvPr>
@@ -17949,7 +17887,7 @@
         <p:spPr>
           <a:xfrm>
             <a:off x="649605" y="1277620"/>
-            <a:ext cx="3773469" cy="1087477"/>
+            <a:ext cx="10797828" cy="1087477"/>
           </a:xfrm>
           <a:prstGeom prst="rect">
             <a:avLst/>
@@ -17991,17 +17929,17 @@
                 <a:latin typeface="Meiryo UI" panose="020B0604030504040204" pitchFamily="34" charset="-128"/>
                 <a:ea typeface="Meiryo UI" panose="020B0604030504040204" pitchFamily="34" charset="-128"/>
               </a:rPr>
-              <a:t>Resource</a:t>
+              <a:t>Changed Module:[module]</a:t>
             </a:r>
           </a:p>
         </p:txBody>
       </p:sp>
       <p:pic>
         <p:nvPicPr>
-          <p:cNvPr id="6" name="图片 5">
+          <p:cNvPr id="3" name="图片 2">
             <a:extLst>
               <a:ext uri="{FF2B5EF4-FFF2-40B4-BE49-F238E27FC236}">
-                <a16:creationId xmlns:a16="http://schemas.microsoft.com/office/drawing/2014/main" id="{3ADA0DAF-FC82-576B-8D42-86F5137E1CA1}"/>
+                <a16:creationId xmlns:a16="http://schemas.microsoft.com/office/drawing/2014/main" id="{4D8D743C-F172-CF51-5B3E-4C4F63513EE0}"/>
               </a:ext>
             </a:extLst>
           </p:cNvPr>
@@ -18018,18 +17956,80 @@
         </p:blipFill>
         <p:spPr>
           <a:xfrm>
-            <a:off x="5038378" y="6540303"/>
-            <a:ext cx="12532328" cy="3693943"/>
+            <a:off x="4807129" y="5540348"/>
+            <a:ext cx="15187492" cy="4822852"/>
           </a:xfrm>
           <a:prstGeom prst="rect">
             <a:avLst/>
           </a:prstGeom>
         </p:spPr>
       </p:pic>
+      <p:sp>
+        <p:nvSpPr>
+          <p:cNvPr id="4" name="文本框 3">
+            <a:extLst>
+              <a:ext uri="{FF2B5EF4-FFF2-40B4-BE49-F238E27FC236}">
+                <a16:creationId xmlns:a16="http://schemas.microsoft.com/office/drawing/2014/main" id="{33C83B96-6DD2-8EA4-60C9-11D67C7E21CD}"/>
+              </a:ext>
+            </a:extLst>
+          </p:cNvPr>
+          <p:cNvSpPr txBox="1"/>
+          <p:nvPr/>
+        </p:nvSpPr>
+        <p:spPr>
+          <a:xfrm>
+            <a:off x="12673440" y="1272978"/>
+            <a:ext cx="6530634" cy="1087477"/>
+          </a:xfrm>
+          <a:prstGeom prst="rect">
+            <a:avLst/>
+          </a:prstGeom>
+          <a:noFill/>
+          <a:ln w="12700" cap="flat">
+            <a:noFill/>
+            <a:miter lim="400000"/>
+          </a:ln>
+        </p:spPr>
+        <p:style>
+          <a:lnRef idx="0">
+            <a:scrgbClr r="0" g="0" b="0"/>
+          </a:lnRef>
+          <a:fillRef idx="0">
+            <a:scrgbClr r="0" g="0" b="0"/>
+          </a:fillRef>
+          <a:effectRef idx="0">
+            <a:scrgbClr r="0" g="0" b="0"/>
+          </a:effectRef>
+          <a:fontRef idx="none"/>
+        </p:style>
+        <p:txBody>
+          <a:bodyPr rot="0" vertOverflow="overflow" horzOverflow="overflow" vert="horz" wrap="none" lIns="50800" tIns="50800" rIns="50800" bIns="50800" numCol="1" spcCol="38100" rtlCol="0" anchor="t" forceAA="0">
+            <a:spAutoFit/>
+          </a:bodyPr>
+          <a:lstStyle/>
+          <a:p>
+            <a:pPr lvl="0" algn="l">
+              <a:defRPr/>
+            </a:pPr>
+            <a:r>
+              <a:rPr lang="en-US" altLang="zh-CN" sz="6400" dirty="0">
+                <a:solidFill>
+                  <a:srgbClr val="434343">
+                    <a:lumMod val="50000"/>
+                  </a:srgbClr>
+                </a:solidFill>
+                <a:latin typeface="Meiryo UI" panose="020B0604030504040204" pitchFamily="34" charset="-128"/>
+                <a:ea typeface="Meiryo UI" panose="020B0604030504040204" pitchFamily="34" charset="-128"/>
+              </a:rPr>
+              <a:t>Self Test Report</a:t>
+            </a:r>
+          </a:p>
+        </p:txBody>
+      </p:sp>
     </p:spTree>
     <p:extLst>
       <p:ext uri="{BB962C8B-B14F-4D97-AF65-F5344CB8AC3E}">
-        <p14:creationId xmlns:p14="http://schemas.microsoft.com/office/powerpoint/2010/main" val="4164179808"/>
+        <p14:creationId xmlns:p14="http://schemas.microsoft.com/office/powerpoint/2010/main" val="1037475528"/>
       </p:ext>
     </p:extLst>
   </p:cSld>

</xml_diff>

<commit_message>
[2026-05-29 UTC] JST add PowerPoint export with ppt_exporter module
1. src/main.py: add --ppt flag and PPTTemplateFiller integration
2. src/ppt_exporter.py: add PPTX template filler for JIRA ticket reports
3. requirements.txt: add python-pptx dependency
4. PPTTemplate/Template.pptx: update template for PPTX generation

Co-authored-by: Cursor <cursoragent@cursor.com>
</commit_message>
<xml_diff>
--- a/PPTTemplate/Template.pptx
+++ b/PPTTemplate/Template.pptx
@@ -17193,14 +17193,14 @@
           <p:nvPr>
             <p:extLst>
               <p:ext uri="{D42A27DB-BD31-4B8C-83A1-F6EECF244321}">
-                <p14:modId xmlns:p14="http://schemas.microsoft.com/office/powerpoint/2010/main" val="1992209824"/>
+                <p14:modId xmlns:p14="http://schemas.microsoft.com/office/powerpoint/2010/main" val="2799925240"/>
               </p:ext>
             </p:extLst>
           </p:nvPr>
         </p:nvGraphicFramePr>
         <p:xfrm>
           <a:off x="3118797" y="1617786"/>
-          <a:ext cx="17523914" cy="2535110"/>
+          <a:ext cx="17523914" cy="1267555"/>
         </p:xfrm>
         <a:graphic>
           <a:graphicData uri="http://schemas.openxmlformats.org/drawingml/2006/table">
@@ -17232,13 +17232,18 @@
                         <a:buNone/>
                       </a:pPr>
                       <a:r>
-                        <a:rPr lang="en-US" sz="3600" dirty="0">
+                        <a:rPr lang="en-US" sz="3600">
                           <a:latin typeface="Calibri" panose="020F0502020204030204" pitchFamily="34" charset="0"/>
                           <a:ea typeface="Calibri" panose="020F0502020204030204" pitchFamily="34" charset="0"/>
                           <a:cs typeface="Calibri" panose="020F0502020204030204" pitchFamily="34" charset="0"/>
                         </a:rPr>
-                        <a:t>Module</a:t>
+                        <a:t>MODULE</a:t>
                       </a:r>
+                      <a:endParaRPr lang="en-US" sz="3600" dirty="0">
+                        <a:latin typeface="Calibri" panose="020F0502020204030204" pitchFamily="34" charset="0"/>
+                        <a:ea typeface="Calibri" panose="020F0502020204030204" pitchFamily="34" charset="0"/>
+                        <a:cs typeface="Calibri" panose="020F0502020204030204" pitchFamily="34" charset="0"/>
+                      </a:endParaRPr>
                     </a:p>
                   </a:txBody>
                   <a:tcPr marL="23070" marR="23070" marT="11535" marB="11535" anchor="ctr">
@@ -17314,20 +17319,7 @@
                           <a:cs typeface="Calibri" panose="020F0502020204030204" pitchFamily="34" charset="0"/>
                           <a:sym typeface="Helvetica"/>
                         </a:rPr>
-                        <a:t>T</a:t>
-                      </a:r>
-                      <a:r>
-                        <a:rPr lang="en-US" altLang="zh-CN" sz="3600" b="0" i="0" u="none" strike="noStrike" cap="none" spc="0" baseline="0" dirty="0" err="1">
-                          <a:solidFill>
-                            <a:schemeClr val="tx1"/>
-                          </a:solidFill>
-                          <a:uFillTx/>
-                          <a:latin typeface="Calibri" panose="020F0502020204030204" pitchFamily="34" charset="0"/>
-                          <a:ea typeface="Calibri" panose="020F0502020204030204" pitchFamily="34" charset="0"/>
-                          <a:cs typeface="Calibri" panose="020F0502020204030204" pitchFamily="34" charset="0"/>
-                          <a:sym typeface="Helvetica"/>
-                        </a:rPr>
-                        <a:t>icket</a:t>
+                        <a:t>ID</a:t>
                       </a:r>
                       <a:endParaRPr lang="en-US" altLang="zh-CN" sz="3600" b="0" i="0" u="none" strike="noStrike" cap="none" spc="0" baseline="0" dirty="0">
                         <a:solidFill>
@@ -17387,126 +17379,6 @@
                   </a:ext>
                 </a:extLst>
               </a:tr>
-              <a:tr h="1267555">
-                <a:tc>
-                  <a:txBody>
-                    <a:bodyPr/>
-                    <a:lstStyle/>
-                    <a:p>
-                      <a:pPr algn="ctr">
-                        <a:buNone/>
-                      </a:pPr>
-                      <a:endParaRPr lang="en-US" sz="3600" dirty="0">
-                        <a:latin typeface="Calibri" panose="020F0502020204030204" pitchFamily="34" charset="0"/>
-                        <a:ea typeface="Calibri" panose="020F0502020204030204" pitchFamily="34" charset="0"/>
-                        <a:cs typeface="Calibri" panose="020F0502020204030204" pitchFamily="34" charset="0"/>
-                      </a:endParaRPr>
-                    </a:p>
-                  </a:txBody>
-                  <a:tcPr marL="23070" marR="23070" marT="11535" marB="11535" anchor="ctr">
-                    <a:lnL w="12700" cap="flat" cmpd="sng" algn="ctr">
-                      <a:solidFill>
-                        <a:schemeClr val="tx1"/>
-                      </a:solidFill>
-                      <a:prstDash val="solid"/>
-                      <a:round/>
-                      <a:headEnd type="none" w="med" len="med"/>
-                      <a:tailEnd type="none" w="med" len="med"/>
-                    </a:lnL>
-                    <a:lnR w="12700" cap="flat" cmpd="sng" algn="ctr">
-                      <a:solidFill>
-                        <a:schemeClr val="tx1"/>
-                      </a:solidFill>
-                      <a:prstDash val="solid"/>
-                      <a:round/>
-                      <a:headEnd type="none" w="med" len="med"/>
-                      <a:tailEnd type="none" w="med" len="med"/>
-                    </a:lnR>
-                    <a:lnT w="12700" cap="flat" cmpd="sng" algn="ctr">
-                      <a:solidFill>
-                        <a:schemeClr val="tx1"/>
-                      </a:solidFill>
-                      <a:prstDash val="solid"/>
-                      <a:round/>
-                      <a:headEnd type="none" w="med" len="med"/>
-                      <a:tailEnd type="none" w="med" len="med"/>
-                    </a:lnT>
-                    <a:lnB w="12700" cap="flat" cmpd="sng" algn="ctr">
-                      <a:solidFill>
-                        <a:schemeClr val="tx1"/>
-                      </a:solidFill>
-                      <a:prstDash val="solid"/>
-                      <a:round/>
-                      <a:headEnd type="none" w="med" len="med"/>
-                      <a:tailEnd type="none" w="med" len="med"/>
-                    </a:lnB>
-                    <a:noFill/>
-                  </a:tcPr>
-                </a:tc>
-                <a:tc>
-                  <a:txBody>
-                    <a:bodyPr/>
-                    <a:lstStyle/>
-                    <a:p>
-                      <a:pPr algn="ctr"/>
-                      <a:endParaRPr lang="en-US" altLang="zh-CN" sz="3600" b="0" i="0" u="none" strike="noStrike" cap="none" spc="0" baseline="0" dirty="0">
-                        <a:solidFill>
-                          <a:schemeClr val="tx1"/>
-                        </a:solidFill>
-                        <a:uFillTx/>
-                        <a:latin typeface="Calibri" panose="020F0502020204030204" pitchFamily="34" charset="0"/>
-                        <a:ea typeface="Calibri" panose="020F0502020204030204" pitchFamily="34" charset="0"/>
-                        <a:cs typeface="Calibri" panose="020F0502020204030204" pitchFamily="34" charset="0"/>
-                        <a:sym typeface="Helvetica"/>
-                      </a:endParaRPr>
-                    </a:p>
-                  </a:txBody>
-                  <a:tcPr marL="23070" marR="23070" marT="11535" marB="11535" anchor="ctr">
-                    <a:lnL w="12700" cap="flat" cmpd="sng" algn="ctr">
-                      <a:solidFill>
-                        <a:schemeClr val="tx1"/>
-                      </a:solidFill>
-                      <a:prstDash val="solid"/>
-                      <a:round/>
-                      <a:headEnd type="none" w="med" len="med"/>
-                      <a:tailEnd type="none" w="med" len="med"/>
-                    </a:lnL>
-                    <a:lnR w="12700" cap="flat" cmpd="sng" algn="ctr">
-                      <a:solidFill>
-                        <a:schemeClr val="tx1"/>
-                      </a:solidFill>
-                      <a:prstDash val="solid"/>
-                      <a:round/>
-                      <a:headEnd type="none" w="med" len="med"/>
-                      <a:tailEnd type="none" w="med" len="med"/>
-                    </a:lnR>
-                    <a:lnT w="12700" cap="flat" cmpd="sng" algn="ctr">
-                      <a:solidFill>
-                        <a:schemeClr val="tx1"/>
-                      </a:solidFill>
-                      <a:prstDash val="solid"/>
-                      <a:round/>
-                      <a:headEnd type="none" w="med" len="med"/>
-                      <a:tailEnd type="none" w="med" len="med"/>
-                    </a:lnT>
-                    <a:lnB w="12700" cap="flat" cmpd="sng" algn="ctr">
-                      <a:solidFill>
-                        <a:schemeClr val="tx1"/>
-                      </a:solidFill>
-                      <a:prstDash val="solid"/>
-                      <a:round/>
-                      <a:headEnd type="none" w="med" len="med"/>
-                      <a:tailEnd type="none" w="med" len="med"/>
-                    </a:lnB>
-                    <a:noFill/>
-                  </a:tcPr>
-                </a:tc>
-                <a:extLst>
-                  <a:ext uri="{0D108BD9-81ED-4DB2-BD59-A6C34878D82A}">
-                    <a16:rowId xmlns:a16="http://schemas.microsoft.com/office/drawing/2014/main" val="2609363112"/>
-                  </a:ext>
-                </a:extLst>
-              </a:tr>
             </a:tbl>
           </a:graphicData>
         </a:graphic>
@@ -17719,7 +17591,7 @@
         <p:spPr>
           <a:xfrm>
             <a:off x="12673440" y="1272978"/>
-            <a:ext cx="3342262" cy="1087477"/>
+            <a:ext cx="1476366" cy="1087477"/>
           </a:xfrm>
           <a:prstGeom prst="rect">
             <a:avLst/>
@@ -17761,7 +17633,7 @@
                 <a:latin typeface="Meiryo UI" panose="020B0604030504040204" pitchFamily="34" charset="-128"/>
                 <a:ea typeface="Meiryo UI" panose="020B0604030504040204" pitchFamily="34" charset="-128"/>
               </a:rPr>
-              <a:t>Solution</a:t>
+              <a:t>Diff</a:t>
             </a:r>
           </a:p>
         </p:txBody>
@@ -17872,68 +17744,6 @@
           </a:p>
         </p:txBody>
       </p:sp>
-      <p:sp>
-        <p:nvSpPr>
-          <p:cNvPr id="8" name="文本框 7">
-            <a:extLst>
-              <a:ext uri="{FF2B5EF4-FFF2-40B4-BE49-F238E27FC236}">
-                <a16:creationId xmlns:a16="http://schemas.microsoft.com/office/drawing/2014/main" id="{DC0C2705-06BA-0023-569E-65804D90507E}"/>
-              </a:ext>
-            </a:extLst>
-          </p:cNvPr>
-          <p:cNvSpPr txBox="1"/>
-          <p:nvPr/>
-        </p:nvSpPr>
-        <p:spPr>
-          <a:xfrm>
-            <a:off x="649605" y="1277620"/>
-            <a:ext cx="10797828" cy="1087477"/>
-          </a:xfrm>
-          <a:prstGeom prst="rect">
-            <a:avLst/>
-          </a:prstGeom>
-          <a:noFill/>
-          <a:ln w="12700" cap="flat">
-            <a:noFill/>
-            <a:miter lim="400000"/>
-          </a:ln>
-        </p:spPr>
-        <p:style>
-          <a:lnRef idx="0">
-            <a:scrgbClr r="0" g="0" b="0"/>
-          </a:lnRef>
-          <a:fillRef idx="0">
-            <a:scrgbClr r="0" g="0" b="0"/>
-          </a:fillRef>
-          <a:effectRef idx="0">
-            <a:scrgbClr r="0" g="0" b="0"/>
-          </a:effectRef>
-          <a:fontRef idx="none"/>
-        </p:style>
-        <p:txBody>
-          <a:bodyPr rot="0" vertOverflow="overflow" horzOverflow="overflow" vert="horz" wrap="none" lIns="50800" tIns="50800" rIns="50800" bIns="50800" numCol="1" spcCol="38100" rtlCol="0" anchor="t" forceAA="0">
-            <a:spAutoFit/>
-          </a:bodyPr>
-          <a:lstStyle/>
-          <a:p>
-            <a:pPr lvl="0" algn="l">
-              <a:defRPr/>
-            </a:pPr>
-            <a:r>
-              <a:rPr lang="en-US" altLang="zh-CN" sz="6400" dirty="0">
-                <a:solidFill>
-                  <a:srgbClr val="434343">
-                    <a:lumMod val="50000"/>
-                  </a:srgbClr>
-                </a:solidFill>
-                <a:latin typeface="Meiryo UI" panose="020B0604030504040204" pitchFamily="34" charset="-128"/>
-                <a:ea typeface="Meiryo UI" panose="020B0604030504040204" pitchFamily="34" charset="-128"/>
-              </a:rPr>
-              <a:t>Changed Module:[module]</a:t>
-            </a:r>
-          </a:p>
-        </p:txBody>
-      </p:sp>
       <p:pic>
         <p:nvPicPr>
           <p:cNvPr id="3" name="图片 2">
@@ -18022,6 +17832,68 @@
                 <a:ea typeface="Meiryo UI" panose="020B0604030504040204" pitchFamily="34" charset="-128"/>
               </a:rPr>
               <a:t>Self Test Report</a:t>
+            </a:r>
+          </a:p>
+        </p:txBody>
+      </p:sp>
+      <p:sp>
+        <p:nvSpPr>
+          <p:cNvPr id="2" name="文本框 1">
+            <a:extLst>
+              <a:ext uri="{FF2B5EF4-FFF2-40B4-BE49-F238E27FC236}">
+                <a16:creationId xmlns:a16="http://schemas.microsoft.com/office/drawing/2014/main" id="{98AA5B65-BF3C-37BA-BBFF-E961FA80168C}"/>
+              </a:ext>
+            </a:extLst>
+          </p:cNvPr>
+          <p:cNvSpPr txBox="1"/>
+          <p:nvPr/>
+        </p:nvSpPr>
+        <p:spPr>
+          <a:xfrm>
+            <a:off x="649605" y="1277620"/>
+            <a:ext cx="3683701" cy="1087477"/>
+          </a:xfrm>
+          <a:prstGeom prst="rect">
+            <a:avLst/>
+          </a:prstGeom>
+          <a:noFill/>
+          <a:ln w="12700" cap="flat">
+            <a:noFill/>
+            <a:miter lim="400000"/>
+          </a:ln>
+        </p:spPr>
+        <p:style>
+          <a:lnRef idx="0">
+            <a:scrgbClr r="0" g="0" b="0"/>
+          </a:lnRef>
+          <a:fillRef idx="0">
+            <a:scrgbClr r="0" g="0" b="0"/>
+          </a:fillRef>
+          <a:effectRef idx="0">
+            <a:scrgbClr r="0" g="0" b="0"/>
+          </a:effectRef>
+          <a:fontRef idx="none"/>
+        </p:style>
+        <p:txBody>
+          <a:bodyPr rot="0" vertOverflow="overflow" horzOverflow="overflow" vert="horz" wrap="none" lIns="50800" tIns="50800" rIns="50800" bIns="50800" numCol="1" spcCol="38100" rtlCol="0" anchor="t" forceAA="0">
+            <a:spAutoFit/>
+          </a:bodyPr>
+          <a:lstStyle/>
+          <a:p>
+            <a:pPr lvl="0" algn="l">
+              <a:defRPr/>
+            </a:pPr>
+            <a:r>
+              <a:rPr lang="en-US" altLang="zh-CN" sz="6400" dirty="0">
+                <a:solidFill>
+                  <a:srgbClr val="434343">
+                    <a:lumMod val="50000"/>
+                  </a:srgbClr>
+                </a:solidFill>
+                <a:latin typeface="Meiryo UI" panose="020B0604030504040204" pitchFamily="34" charset="-128"/>
+                <a:ea typeface="Meiryo UI" panose="020B0604030504040204" pitchFamily="34" charset="-128"/>
+              </a:rPr>
+              <a:t>[Module]</a:t>
             </a:r>
           </a:p>
         </p:txBody>

</xml_diff>

<commit_message>
Refactor project: add definition layer, remove discover module, update config and PPT exporter
- Add src/definition.py for centralized data definitions

- Remove src/discover.py, run_discover.bat, temp_show_cf.py

- Refactor client.py, exporter.py, ppt_exporter.py, main.py

- Add config.json.example and design documents

- Update PPT template and requirements

- Add config.json to .gitignore
</commit_message>
<xml_diff>
--- a/PPTTemplate/Template.pptx
+++ b/PPTTemplate/Template.pptx
@@ -869,7 +869,7 @@
           <a:p>
             <a:fld id="{0F9B84EA-7D68-4D60-9CB1-D50884785D1C}" type="datetimeFigureOut">
               <a:rPr lang="zh-CN" altLang="en-US" smtClean="0"/>
-              <a:t>2026/5/29</a:t>
+              <a:t>2026/6/26</a:t>
             </a:fld>
             <a:endParaRPr lang="zh-CN" altLang="en-US"/>
           </a:p>
@@ -14070,7 +14070,7 @@
           <a:p>
             <a:fld id="{AD47BF0B-C5F6-456B-99D9-1E84273BA548}" type="datetimeFigureOut">
               <a:rPr lang="zh-CN" altLang="en-US" smtClean="0"/>
-              <a:t>2026/5/29</a:t>
+              <a:t>2026/6/26</a:t>
             </a:fld>
             <a:endParaRPr lang="zh-CN" altLang="en-US"/>
           </a:p>
@@ -17591,7 +17591,7 @@
         <p:spPr>
           <a:xfrm>
             <a:off x="12673440" y="1272978"/>
-            <a:ext cx="1476366" cy="1087477"/>
+            <a:ext cx="3342262" cy="1087477"/>
           </a:xfrm>
           <a:prstGeom prst="rect">
             <a:avLst/>
@@ -17624,7 +17624,7 @@
               <a:defRPr/>
             </a:pPr>
             <a:r>
-              <a:rPr lang="en-US" altLang="zh-CN" sz="6400" dirty="0">
+              <a:rPr lang="en-US" altLang="zh-CN" sz="6400">
                 <a:solidFill>
                   <a:srgbClr val="434343">
                     <a:lumMod val="50000"/>
@@ -17633,8 +17633,17 @@
                 <a:latin typeface="Meiryo UI" panose="020B0604030504040204" pitchFamily="34" charset="-128"/>
                 <a:ea typeface="Meiryo UI" panose="020B0604030504040204" pitchFamily="34" charset="-128"/>
               </a:rPr>
-              <a:t>Diff</a:t>
-            </a:r>
+              <a:t>Solution</a:t>
+            </a:r>
+            <a:endParaRPr lang="en-US" altLang="zh-CN" sz="6400" dirty="0">
+              <a:solidFill>
+                <a:srgbClr val="434343">
+                  <a:lumMod val="50000"/>
+                </a:srgbClr>
+              </a:solidFill>
+              <a:latin typeface="Meiryo UI" panose="020B0604030504040204" pitchFamily="34" charset="-128"/>
+              <a:ea typeface="Meiryo UI" panose="020B0604030504040204" pitchFamily="34" charset="-128"/>
+            </a:endParaRPr>
           </a:p>
         </p:txBody>
       </p:sp>
@@ -17744,36 +17753,6 @@
           </a:p>
         </p:txBody>
       </p:sp>
-      <p:pic>
-        <p:nvPicPr>
-          <p:cNvPr id="3" name="图片 2">
-            <a:extLst>
-              <a:ext uri="{FF2B5EF4-FFF2-40B4-BE49-F238E27FC236}">
-                <a16:creationId xmlns:a16="http://schemas.microsoft.com/office/drawing/2014/main" id="{4D8D743C-F172-CF51-5B3E-4C4F63513EE0}"/>
-              </a:ext>
-            </a:extLst>
-          </p:cNvPr>
-          <p:cNvPicPr>
-            <a:picLocks noChangeAspect="1"/>
-          </p:cNvPicPr>
-          <p:nvPr/>
-        </p:nvPicPr>
-        <p:blipFill>
-          <a:blip r:embed="rId2"/>
-          <a:stretch>
-            <a:fillRect/>
-          </a:stretch>
-        </p:blipFill>
-        <p:spPr>
-          <a:xfrm>
-            <a:off x="4807129" y="5540348"/>
-            <a:ext cx="15187492" cy="4822852"/>
-          </a:xfrm>
-          <a:prstGeom prst="rect">
-            <a:avLst/>
-          </a:prstGeom>
-        </p:spPr>
-      </p:pic>
       <p:sp>
         <p:nvSpPr>
           <p:cNvPr id="4" name="文本框 3">

</xml_diff>